<commit_message>
docs(slides): slide 3 thêm kết quả red team 72 ca (66 → 72/72) kèm giới hạn
Co-Authored-By: Claude Opus 5.5 <noreply@anthropic.com>
</commit_message>
<xml_diff>
--- a/docs/submission/Tax-Referee-5-slides.pptx
+++ b/docs/submission/Tax-Referee-5-slides.pptx
@@ -111,27 +111,27 @@
   <p:extLst>
     <p:ext uri="{521415D9-36F7-43E2-AB2F-B90AF26B5E84}">
       <p14:sectionLst xmlns:p14="http://schemas.microsoft.com/office/powerpoint/2010/main">
-        <p14:section name="1 · Vấn đề" id="{9cd75de9-358b-993c-3822-aefd2953db36}">
+        <p14:section name="1 · Vấn đề" id="{891286f9-7456-8608-daa4-820f2c7a2bb5}">
           <p14:sldIdLst>
             <p14:sldId id="256"/>
           </p14:sldIdLst>
         </p14:section>
-        <p14:section name="2 · Đầu vào → Xử lý → Đầu ra" id="{ccc2ff38-5695-4dd7-e3e5-cbea570cbd80}">
+        <p14:section name="2 · Đầu vào → Xử lý → Đầu ra" id="{19cf9828-06f5-a373-7ff1-3bde21485b2f}">
           <p14:sldIdLst>
             <p14:sldId id="257"/>
           </p14:sldIdLst>
         </p14:section>
-        <p14:section name="3 · Tác động" id="{df9d4313-e0f9-de7b-8f1a-c08965d93324}">
+        <p14:section name="3 · Tác động" id="{1c6a4c70-2b3a-2f9c-a02b-77213cd8c631}">
           <p14:sldIdLst>
             <p14:sldId id="258"/>
           </p14:sldIdLst>
         </p14:section>
-        <p14:section name="4 · Kiến trúc" id="{e3d320ce-d85c-ffde-335d-0945a7252a26}">
+        <p14:section name="4 · Kiến trúc" id="{d4f3dec4-5a6f-8e40-a462-d67acbb989b7}">
           <p14:sldIdLst>
             <p14:sldId id="259"/>
           </p14:sldIdLst>
         </p14:section>
-        <p14:section name="5 · Giới hạn và rủi ro" id="{d97203d5-eb93-13e4-ace0-432bcbc2b518}">
+        <p14:section name="5 · Giới hạn và rủi ro" id="{f305a9d3-a3b0-6cfb-40aa-b3bf1635ee68}">
           <p14:sldIdLst>
             <p14:sldId id="260"/>
           </p14:sldIdLst>
@@ -716,7 +716,7 @@
           <a:p>
             <a:r>
               <a:rPr lang="en-US" dirty="0"/>
-              <a:t>Số liệu A đo trên hệ thống, tái lập bằng scripts/qa/compare-rehearsal.ts (docs/evidence/before-after-judge-rehearsal-2026-10-14.md): đúng 3/11 → 11/11, hỏi thừa 3/3 → 0/3, sai nhóm 4/8 → 0/8, câu hỏi cụ thể 1/10 → 8/8. Nói rõ giới hạn. Ô người dùng chỉ điền số thật ngày 16/10; nếu chưa có, nói "chưa có".</a:t>
+              <a:t>Số liệu A đo trên hệ thống, tái lập bằng scripts/qa/compare-rehearsal.ts (docs/evidence/before-after-judge-rehearsal-2026-10-14.md): đúng 3/11 → 11/11, hỏi thừa 3/3 → 0/3, sai nhóm 4/8 → 0/8, câu hỏi cụ thể 1/10 → 8/8. Red team: 72 ca bẫy do agent viết từ SOP mà không đọc mã engine, lần đầu đúng 66/72, sau khi sửa 72/72, nay là bộ hồi quy trong npm test (data/verification/redteam/cases.json). Nói rõ giới hạn. Ô người dùng chỉ điền số thật ngày 16/10; nếu chưa có, nói "chưa có".</a:t>
             </a:r>
             <a:endParaRPr lang="en-US" dirty="0"/>
           </a:p>
@@ -4195,7 +4195,7 @@
                   <a:schemeClr val="tx1"/>
                 </a:solidFill>
               </a:rPr>
-              <a:t>Cùng 11 ca, cùng script, 2 phiên bản mã nguồn</a:t>
+              <a:t>11 ca, 2 bản mã, DB tạm, không gọi AI</a:t>
             </a:r>
             <a:endParaRPr lang="en-US" sz="1200" dirty="0"/>
           </a:p>
@@ -4213,7 +4213,7 @@
                   <a:schemeClr val="tx1"/>
                 </a:solidFill>
               </a:rPr>
-              <a:t>Mỗi ca một database tạm, không gọi AI</a:t>
+              <a:t>72 ca bẫy agent viết từ SOP: 66 → 72/72</a:t>
             </a:r>
             <a:endParaRPr lang="en-US" sz="1200" dirty="0"/>
           </a:p>
@@ -4231,7 +4231,7 @@
                   <a:schemeClr val="tx1"/>
                 </a:solidFill>
               </a:rPr>
-              <a:t>Giới hạn: ca do đội viết — tập phát triển, chưa phải đánh giá độc lập</a:t>
+              <a:t>Giới hạn: ca do đội/AI viết — chưa phải đánh giá độc lập</a:t>
             </a:r>
             <a:endParaRPr lang="en-US" sz="1200" dirty="0"/>
           </a:p>

</xml_diff>

<commit_message>
docs(slides): Slide 3 ghi đúng chỉ số "câu hỏi" là kiểm tra tự động; ghi chú mẫu số và cách tái lập
Co-Authored-By: Claude Opus 5.5 <noreply@anthropic.com>
</commit_message>
<xml_diff>
--- a/docs/submission/Tax-Referee-5-slides.pptx
+++ b/docs/submission/Tax-Referee-5-slides.pptx
@@ -111,27 +111,27 @@
   <p:extLst>
     <p:ext uri="{521415D9-36F7-43E2-AB2F-B90AF26B5E84}">
       <p14:sectionLst xmlns:p14="http://schemas.microsoft.com/office/powerpoint/2010/main">
-        <p14:section name="1 · Vấn đề" id="{891286f9-7456-8608-daa4-820f2c7a2bb5}">
+        <p14:section name="1 · Vấn đề" id="{60d7db1d-c610-4710-dbce-22a062a97172}">
           <p14:sldIdLst>
             <p14:sldId id="256"/>
           </p14:sldIdLst>
         </p14:section>
-        <p14:section name="2 · Đầu vào → Xử lý → Đầu ra" id="{19cf9828-06f5-a373-7ff1-3bde21485b2f}">
+        <p14:section name="2 · Đầu vào → Xử lý → Đầu ra" id="{3ef0afc0-4bf2-0222-f41f-63f6ab2c9cbe}">
           <p14:sldIdLst>
             <p14:sldId id="257"/>
           </p14:sldIdLst>
         </p14:section>
-        <p14:section name="3 · Tác động" id="{1c6a4c70-2b3a-2f9c-a02b-77213cd8c631}">
+        <p14:section name="3 · Tác động" id="{5fe31499-b952-5cbf-486b-56e90f00c1d7}">
           <p14:sldIdLst>
             <p14:sldId id="258"/>
           </p14:sldIdLst>
         </p14:section>
-        <p14:section name="4 · Kiến trúc" id="{d4f3dec4-5a6f-8e40-a462-d67acbb989b7}">
+        <p14:section name="4 · Kiến trúc" id="{a51b8ac6-e632-ee58-43cb-d97cb0673ae1}">
           <p14:sldIdLst>
             <p14:sldId id="259"/>
           </p14:sldIdLst>
         </p14:section>
-        <p14:section name="5 · Giới hạn và rủi ro" id="{f305a9d3-a3b0-6cfb-40aa-b3bf1635ee68}">
+        <p14:section name="5 · Giới hạn và rủi ro" id="{e1d2edf7-89df-1202-e130-7fe716371a9a}">
           <p14:sldIdLst>
             <p14:sldId id="260"/>
           </p14:sldIdLst>
@@ -716,7 +716,7 @@
           <a:p>
             <a:r>
               <a:rPr lang="en-US" dirty="0"/>
-              <a:t>Số liệu A đo trên hệ thống, tái lập bằng scripts/qa/compare-rehearsal.ts (docs/evidence/before-after-judge-rehearsal-2026-10-14.md): đúng 3/11 → 11/11, hỏi thừa 3/3 → 0/3, sai nhóm 4/8 → 0/8, câu hỏi cụ thể 1/10 → 8/8. Red team: 72 ca bẫy do agent viết từ SOP mà không đọc mã engine, lần đầu đúng 66/72, sau khi sửa 72/72, nay là bộ hồi quy trong npm test (data/verification/redteam/cases.json). Nói rõ giới hạn. Ô người dùng chỉ điền số thật ngày 16/10; nếu chưa có, nói "chưa có".</a:t>
+              <a:t>Số liệu A đo trên hệ thống, tái lập bằng scripts/qa/compare-rehearsal.ts (docs/evidence/before-after-judge-rehearsal-2026-10-14.md): đúng 3/11 → 11/11, hỏi thừa 3/3 → 0/3, sai nhóm 4/8 → 0/8, câu hỏi qua kiểm tra tự động (có số tiền ₫, không chứa “chứng từ gốc/xem danh sách”) 1/10 → 8/8 — mẫu số khác nhau: bản cũ chuyển tiếp 10 ca gồm 3 ca thường quy bị hỏi thừa, bản mới 8 ca. Tái lập: chạy compare-rehearsal.ts với thư mục làm việc là phiên bản cần đo (xem file evidence). Red team: 72 ca bẫy do agent viết từ SOP (không đọc policyEngine.ts, có đọc SOP và module ngưỡng; nhãn do AI gán), lần đầu đúng 66/72, sau khi sửa 72/72, nay là bộ hồi quy trong npm test (data/verification/redteam/cases.json). Nói rõ giới hạn. Ô người dùng chỉ điền số thật ngày 16/10; nếu chưa có, nói "chưa có".</a:t>
             </a:r>
             <a:endParaRPr lang="en-US" dirty="0"/>
           </a:p>
@@ -4104,7 +4104,7 @@
                   <a:schemeClr val="tx1"/>
                 </a:solidFill>
               </a:rPr>
-              <a:t>câu hỏi có số tiền cụ thể, không bắt mở lại chứng từ</a:t>
+              <a:t>câu hỏi có số ₫, không đòi chứng từ gốc (kiểm tự động)</a:t>
             </a:r>
             <a:endParaRPr lang="en-US" sz="1200" dirty="0"/>
           </a:p>

</xml_diff>